<commit_message>
Polish presentation hero and configuration slides
</commit_message>
<xml_diff>
--- a/output/presentation/PSUB-Operator-Guide.pptx
+++ b/output/presentation/PSUB-Operator-Guide.pptx
@@ -3095,6 +3095,49 @@
         <p:nvPr/>
       </p:nvGrpSpPr>
       <p:grpSpPr/>
+      <p:sp>
+        <p:nvSpPr>
+          <p:cNvPr id="7" name="Rounded Rectangle 6"/>
+          <p:cNvSpPr/>
+          <p:nvPr/>
+        </p:nvSpPr>
+        <p:spPr>
+          <a:xfrm>
+            <a:off x="5897880" y="1078992"/>
+            <a:ext cx="5577840" cy="4160520"/>
+          </a:xfrm>
+          <a:prstGeom prst="roundRect">
+            <a:avLst/>
+          </a:prstGeom>
+          <a:solidFill>
+            <a:srgbClr val="040A12"/>
+          </a:solidFill>
+          <a:ln>
+            <a:noFill/>
+          </a:ln>
+        </p:spPr>
+        <p:style>
+          <a:lnRef idx="1">
+            <a:schemeClr val="accent1"/>
+          </a:lnRef>
+          <a:fillRef idx="3">
+            <a:schemeClr val="accent1"/>
+          </a:fillRef>
+          <a:effectRef idx="2">
+            <a:schemeClr val="accent1"/>
+          </a:effectRef>
+          <a:fontRef idx="minor">
+            <a:schemeClr val="lt1"/>
+          </a:fontRef>
+        </p:style>
+        <p:txBody>
+          <a:bodyPr rtlCol="0" anchor="ctr"/>
+          <a:lstStyle/>
+          <a:p>
+            <a:pPr algn="ctr"/>
+          </a:p>
+        </p:txBody>
+      </p:sp>
       <p:pic>
         <p:nvPicPr>
           <p:cNvPr id="2" name="Picture 1" descr="background.png"/>
@@ -3171,8 +3214,8 @@
         </p:nvSpPr>
         <p:spPr>
           <a:xfrm>
-            <a:off x="621792" y="868680"/>
-            <a:ext cx="1508760" cy="82296"/>
+            <a:off x="658368" y="896112"/>
+            <a:ext cx="1280160" cy="73152"/>
           </a:xfrm>
           <a:prstGeom prst="rect">
             <a:avLst/>
@@ -3214,8 +3257,8 @@
         </p:nvSpPr>
         <p:spPr>
           <a:xfrm>
-            <a:off x="548640" y="502920"/>
-            <a:ext cx="8138160" cy="822960"/>
+            <a:off x="658368" y="658368"/>
+            <a:ext cx="5120640" cy="868680"/>
           </a:xfrm>
           <a:prstGeom prst="rect">
             <a:avLst/>
@@ -3229,7 +3272,7 @@
           <a:lstStyle/>
           <a:p>
             <a:r>
-              <a:rPr sz="2800" b="1">
+              <a:rPr sz="2700" b="1">
                 <a:solidFill>
                   <a:srgbClr val="E7EEF7"/>
                 </a:solidFill>
@@ -3248,8 +3291,8 @@
         </p:nvSpPr>
         <p:spPr>
           <a:xfrm>
-            <a:off x="594360" y="1170432"/>
-            <a:ext cx="7680960" cy="457200"/>
+            <a:off x="713232" y="1536192"/>
+            <a:ext cx="5029200" cy="594360"/>
           </a:xfrm>
           <a:prstGeom prst="rect">
             <a:avLst/>
@@ -3276,14 +3319,59 @@
       </p:sp>
       <p:sp>
         <p:nvSpPr>
-          <p:cNvPr id="7" name="Rounded Rectangle 6"/>
+          <p:cNvPr id="8" name="Rounded Rectangle 7"/>
           <p:cNvSpPr/>
           <p:nvPr/>
         </p:nvSpPr>
         <p:spPr>
           <a:xfrm>
-            <a:off x="640080" y="5440680"/>
-            <a:ext cx="3246120" cy="292608"/>
+            <a:off x="5760720" y="932688"/>
+            <a:ext cx="5577840" cy="4160520"/>
+          </a:xfrm>
+          <a:prstGeom prst="roundRect">
+            <a:avLst/>
+          </a:prstGeom>
+          <a:solidFill>
+            <a:srgbClr val="F8FAFC"/>
+          </a:solidFill>
+          <a:ln>
+            <a:solidFill>
+              <a:srgbClr val="415A77"/>
+            </a:solidFill>
+          </a:ln>
+        </p:spPr>
+        <p:style>
+          <a:lnRef idx="1">
+            <a:schemeClr val="accent1"/>
+          </a:lnRef>
+          <a:fillRef idx="3">
+            <a:schemeClr val="accent1"/>
+          </a:fillRef>
+          <a:effectRef idx="2">
+            <a:schemeClr val="accent1"/>
+          </a:effectRef>
+          <a:fontRef idx="minor">
+            <a:schemeClr val="lt1"/>
+          </a:fontRef>
+        </p:style>
+        <p:txBody>
+          <a:bodyPr rtlCol="0" anchor="ctr"/>
+          <a:lstStyle/>
+          <a:p>
+            <a:pPr algn="ctr"/>
+          </a:p>
+        </p:txBody>
+      </p:sp>
+      <p:sp>
+        <p:nvSpPr>
+          <p:cNvPr id="9" name="Rounded Rectangle 8"/>
+          <p:cNvSpPr/>
+          <p:nvPr/>
+        </p:nvSpPr>
+        <p:spPr>
+          <a:xfrm>
+            <a:off x="5989320" y="1133856"/>
+            <a:ext cx="1005840" cy="256032"/>
           </a:xfrm>
           <a:prstGeom prst="roundRect">
             <a:avLst/>
@@ -3315,6 +3403,82 @@
           <a:p>
             <a:pPr algn="ctr"/>
             <a:r>
+              <a:rPr sz="1000" b="1">
+                <a:solidFill>
+                  <a:srgbClr val="121B26"/>
+                </a:solidFill>
+              </a:rPr>
+              <a:t>Web UI</a:t>
+            </a:r>
+          </a:p>
+        </p:txBody>
+      </p:sp>
+      <p:pic>
+        <p:nvPicPr>
+          <p:cNvPr id="10" name="Picture 9" descr="Home.png"/>
+          <p:cNvPicPr>
+            <a:picLocks noChangeAspect="1"/>
+          </p:cNvPicPr>
+          <p:nvPr/>
+        </p:nvPicPr>
+        <p:blipFill>
+          <a:blip r:embed="rId3"/>
+          <a:srcRect/>
+          <a:stretch>
+            <a:fillRect/>
+          </a:stretch>
+        </p:blipFill>
+        <p:spPr>
+          <a:xfrm>
+            <a:off x="5925312" y="1335024"/>
+            <a:ext cx="5230368" cy="3493008"/>
+          </a:xfrm>
+          <a:prstGeom prst="rect">
+            <a:avLst/>
+          </a:prstGeom>
+        </p:spPr>
+      </p:pic>
+      <p:sp>
+        <p:nvSpPr>
+          <p:cNvPr id="11" name="Rounded Rectangle 10"/>
+          <p:cNvSpPr/>
+          <p:nvPr/>
+        </p:nvSpPr>
+        <p:spPr>
+          <a:xfrm>
+            <a:off x="676656" y="5394960"/>
+            <a:ext cx="3246120" cy="292608"/>
+          </a:xfrm>
+          <a:prstGeom prst="roundRect">
+            <a:avLst/>
+          </a:prstGeom>
+          <a:solidFill>
+            <a:srgbClr val="E6BE5A"/>
+          </a:solidFill>
+          <a:ln>
+            <a:noFill/>
+          </a:ln>
+        </p:spPr>
+        <p:style>
+          <a:lnRef idx="1">
+            <a:schemeClr val="accent1"/>
+          </a:lnRef>
+          <a:fillRef idx="3">
+            <a:schemeClr val="accent1"/>
+          </a:fillRef>
+          <a:effectRef idx="2">
+            <a:schemeClr val="accent1"/>
+          </a:effectRef>
+          <a:fontRef idx="minor">
+            <a:schemeClr val="lt1"/>
+          </a:fontRef>
+        </p:style>
+        <p:txBody>
+          <a:bodyPr rtlCol="0" anchor="ctr"/>
+          <a:lstStyle/>
+          <a:p>
+            <a:pPr algn="ctr"/>
+            <a:r>
               <a:rPr sz="1200" b="1">
                 <a:solidFill>
                   <a:srgbClr val="121B26"/>
@@ -3327,7 +3491,7 @@
       </p:sp>
       <p:sp>
         <p:nvSpPr>
-          <p:cNvPr id="8" name="TextBox 7"/>
+          <p:cNvPr id="12" name="TextBox 11"/>
           <p:cNvSpPr txBox="1"/>
           <p:nvPr/>
         </p:nvSpPr>
@@ -3361,7 +3525,7 @@
       </p:sp>
       <p:sp>
         <p:nvSpPr>
-          <p:cNvPr id="9" name="TextBox 8"/>
+          <p:cNvPr id="13" name="TextBox 12"/>
           <p:cNvSpPr txBox="1"/>
           <p:nvPr/>
         </p:nvSpPr>
@@ -5755,7 +5919,7 @@
                   <a:srgbClr val="E7EEF7"/>
                 </a:solidFill>
               </a:rPr>
-              <a:t>Git for Windows on PATH</a:t>
+              <a:t>Git for Windows on PATH (recommended)</a:t>
             </a:r>
           </a:p>
         </p:txBody>
@@ -5952,6 +6116,25 @@
                 <a:latin typeface="Aptos"/>
               </a:rPr>
               <a:t>PSUB links missing prerequisites directly to setup guides.</a:t>
+            </a:r>
+          </a:p>
+          <a:p>
+            <a:pPr>
+              <a:lnSpc>
+                <a:spcPct val="105000"/>
+              </a:lnSpc>
+              <a:spcAft>
+                <a:spcPts val="500"/>
+              </a:spcAft>
+            </a:pPr>
+            <a:r>
+              <a:rPr sz="1300">
+                <a:solidFill>
+                  <a:srgbClr val="E7EEF7"/>
+                </a:solidFill>
+                <a:latin typeface="Aptos"/>
+              </a:rPr>
+              <a:t>Git is useful for repo workflows and metadata, but it no longer blocks readiness.</a:t>
             </a:r>
           </a:p>
           <a:p>
@@ -6176,7 +6359,7 @@
                 </a:solidFill>
                 <a:latin typeface="Aptos Display"/>
               </a:rPr>
-              <a:t>Live UI Walkthrough</a:t>
+              <a:t>Configure The Run</a:t>
             </a:r>
           </a:p>
         </p:txBody>
@@ -6210,7 +6393,7 @@
                 </a:solidFill>
                 <a:latin typeface="Aptos"/>
               </a:rPr>
-              <a:t>Only a few fields matter for a clean run</a:t>
+              <a:t>These are the settings operators actually need to touch</a:t>
             </a:r>
           </a:p>
         </p:txBody>
@@ -6262,7 +6445,7 @@
       </p:sp>
       <p:pic>
         <p:nvPicPr>
-          <p:cNvPr id="7" name="Picture 6" descr="04-build-configuration.png"/>
+          <p:cNvPr id="7" name="Picture 6" descr="configuration-settings.png"/>
           <p:cNvPicPr>
             <a:picLocks noChangeAspect="1"/>
           </p:cNvPicPr>
@@ -6400,7 +6583,7 @@
                 </a:solidFill>
                 <a:latin typeface="Aptos"/>
               </a:rPr>
-              <a:t>Use Auto-Detect to fill Bootstrap Python</a:t>
+              <a:t>Keep the doc-venv name stable unless you have a reason to change it</a:t>
             </a:r>
           </a:p>
           <a:p>
@@ -6419,7 +6602,7 @@
                 </a:solidFill>
                 <a:latin typeface="Aptos"/>
               </a:rPr>
-              <a:t>Confirm SourcePath and doc-venv</a:t>
+              <a:t>Confirm the release output folder and detected Windows SDK</a:t>
             </a:r>
           </a:p>
           <a:p>
@@ -6438,7 +6621,7 @@
                 </a:solidFill>
                 <a:latin typeface="Aptos"/>
               </a:rPr>
-              <a:t>Start Build opens a separate live terminal</a:t>
+              <a:t>Set SourcePath and Bootstrap Python before launch</a:t>
             </a:r>
           </a:p>
           <a:p>
@@ -6457,7 +6640,26 @@
                 </a:solidFill>
                 <a:latin typeface="Aptos"/>
               </a:rPr>
-              <a:t>Focus on the build form, not every control in the page.</a:t>
+              <a:t>Start Build opens a separate terminal with live output</a:t>
+            </a:r>
+          </a:p>
+          <a:p>
+            <a:pPr>
+              <a:lnSpc>
+                <a:spcPct val="105000"/>
+              </a:lnSpc>
+              <a:spcAft>
+                <a:spcPts val="500"/>
+              </a:spcAft>
+            </a:pPr>
+            <a:r>
+              <a:rPr sz="1300">
+                <a:solidFill>
+                  <a:srgbClr val="E7EEF7"/>
+                </a:solidFill>
+                <a:latin typeface="Aptos"/>
+              </a:rPr>
+              <a:t>The UI is doing most of the environment work for the operator.</a:t>
             </a:r>
           </a:p>
         </p:txBody>
@@ -7216,6 +7418,25 @@
               <a:t>Python 3.10 MSI/doc handling and artifact naming are now more robust</a:t>
             </a:r>
           </a:p>
+          <a:p>
+            <a:pPr>
+              <a:lnSpc>
+                <a:spcPct val="105000"/>
+              </a:lnSpc>
+              <a:spcAft>
+                <a:spcPts val="500"/>
+              </a:spcAft>
+            </a:pPr>
+            <a:r>
+              <a:rPr sz="1300">
+                <a:solidFill>
+                  <a:srgbClr val="E7EEF7"/>
+                </a:solidFill>
+                <a:latin typeface="Aptos"/>
+              </a:rPr>
+              <a:t>Git is now treated as recommended rather than a hard blocker in the UI</a:t>
+            </a:r>
+          </a:p>
         </p:txBody>
       </p:sp>
       <p:sp>
@@ -7807,7 +8028,7 @@
                 </a:solidFill>
                 <a:latin typeface="Aptos"/>
               </a:rPr>
-              <a:t>Git missing from PATH</a:t>
+              <a:t>Windows SDK or MSVC toolchains incomplete</a:t>
             </a:r>
           </a:p>
           <a:p>
@@ -7826,7 +8047,7 @@
                 </a:solidFill>
                 <a:latin typeface="Aptos"/>
               </a:rPr>
-              <a:t>Windows SDK or MSVC toolchains incomplete</a:t>
+              <a:t>Wrong bootstrap Python version or alias path</a:t>
             </a:r>
           </a:p>
           <a:p>
@@ -7845,7 +8066,7 @@
                 </a:solidFill>
                 <a:latin typeface="Aptos"/>
               </a:rPr>
-              <a:t>Wrong bootstrap Python version or alias path</a:t>
+              <a:t>Missing doc-venv or Sphinx dependencies</a:t>
             </a:r>
           </a:p>
           <a:p>
@@ -7864,7 +8085,7 @@
                 </a:solidFill>
                 <a:latin typeface="Aptos"/>
               </a:rPr>
-              <a:t>Missing doc-venv or Sphinx dependencies</a:t>
+              <a:t>Python 3.10 WiX or .NET 3.5 dependency issue</a:t>
             </a:r>
           </a:p>
           <a:p>
@@ -7883,7 +8104,7 @@
                 </a:solidFill>
                 <a:latin typeface="Aptos"/>
               </a:rPr>
-              <a:t>Python 3.10 WiX or .NET 3.5 dependency issue</a:t>
+              <a:t>Git warnings from non-Git CPython source trees</a:t>
             </a:r>
           </a:p>
         </p:txBody>
@@ -7925,7 +8146,7 @@
                 </a:solidFill>
                 <a:latin typeface="Aptos"/>
               </a:rPr>
-              <a:t>Install Git for Windows and reopen the shell.</a:t>
+              <a:t>Use the setup guides linked by the prerequisites panel.</a:t>
             </a:r>
           </a:p>
           <a:p>
@@ -7944,7 +8165,7 @@
                 </a:solidFill>
                 <a:latin typeface="Aptos"/>
               </a:rPr>
-              <a:t>Use the setup guides linked by the prerequisites panel.</a:t>
+              <a:t>Switch to a real Python 3.10 or 3.12 executable.</a:t>
             </a:r>
           </a:p>
           <a:p>
@@ -7963,7 +8184,7 @@
                 </a:solidFill>
                 <a:latin typeface="Aptos"/>
               </a:rPr>
-              <a:t>Switch to a real Python 3.10 or 3.12 executable.</a:t>
+              <a:t>Run Setup Virtual Environment before retrying.</a:t>
             </a:r>
           </a:p>
           <a:p>
@@ -7982,7 +8203,7 @@
                 </a:solidFill>
                 <a:latin typeface="Aptos"/>
               </a:rPr>
-              <a:t>Run Setup Virtual Environment before retrying.</a:t>
+              <a:t>Enable .NET Framework 3.5 for older 3.10 MSI flows.</a:t>
             </a:r>
           </a:p>
           <a:p>
@@ -8001,7 +8222,7 @@
                 </a:solidFill>
                 <a:latin typeface="Aptos"/>
               </a:rPr>
-              <a:t>Enable .NET Framework 3.5 for older 3.10 MSI flows.</a:t>
+              <a:t>Treat Git warnings as informational when building from extracted python.org archives.</a:t>
             </a:r>
           </a:p>
         </p:txBody>

</xml_diff>

<commit_message>
Refine presentation screenshot framing
</commit_message>
<xml_diff>
--- a/output/presentation/PSUB-Operator-Guide.pptx
+++ b/output/presentation/PSUB-Operator-Guide.pptx
@@ -6246,6 +6246,49 @@
       <p:grpSpPr/>
       <p:sp>
         <p:nvSpPr>
+          <p:cNvPr id="6" name="Rounded Rectangle 5"/>
+          <p:cNvSpPr/>
+          <p:nvPr/>
+        </p:nvSpPr>
+        <p:spPr>
+          <a:xfrm>
+            <a:off x="658368" y="1828800"/>
+            <a:ext cx="7479792" cy="4133087"/>
+          </a:xfrm>
+          <a:prstGeom prst="roundRect">
+            <a:avLst/>
+          </a:prstGeom>
+          <a:solidFill>
+            <a:srgbClr val="040A12"/>
+          </a:solidFill>
+          <a:ln>
+            <a:noFill/>
+          </a:ln>
+        </p:spPr>
+        <p:style>
+          <a:lnRef idx="1">
+            <a:schemeClr val="accent1"/>
+          </a:lnRef>
+          <a:fillRef idx="3">
+            <a:schemeClr val="accent1"/>
+          </a:fillRef>
+          <a:effectRef idx="2">
+            <a:schemeClr val="accent1"/>
+          </a:effectRef>
+          <a:fontRef idx="minor">
+            <a:schemeClr val="lt1"/>
+          </a:fontRef>
+        </p:style>
+        <p:txBody>
+          <a:bodyPr rtlCol="0" anchor="ctr"/>
+          <a:lstStyle/>
+          <a:p>
+            <a:pPr algn="ctr"/>
+          </a:p>
+        </p:txBody>
+      </p:sp>
+      <p:sp>
+        <p:nvSpPr>
           <p:cNvPr id="2" name="Rectangle 1"/>
           <p:cNvSpPr/>
           <p:nvPr/>
@@ -6400,20 +6443,20 @@
       </p:sp>
       <p:sp>
         <p:nvSpPr>
-          <p:cNvPr id="6" name="Rounded Rectangle 5"/>
+          <p:cNvPr id="7" name="Rounded Rectangle 6"/>
           <p:cNvSpPr/>
           <p:nvPr/>
         </p:nvSpPr>
         <p:spPr>
           <a:xfrm>
-            <a:off x="502920" y="1664208"/>
-            <a:ext cx="7818120" cy="4434840"/>
+            <a:off x="530352" y="1700784"/>
+            <a:ext cx="7479792" cy="4133087"/>
           </a:xfrm>
           <a:prstGeom prst="roundRect">
             <a:avLst/>
           </a:prstGeom>
           <a:solidFill>
-            <a:srgbClr val="F5F8FC"/>
+            <a:srgbClr val="F8FAFC"/>
           </a:solidFill>
           <a:ln>
             <a:solidFill>
@@ -6443,9 +6486,60 @@
           </a:p>
         </p:txBody>
       </p:sp>
+      <p:sp>
+        <p:nvSpPr>
+          <p:cNvPr id="8" name="Rounded Rectangle 7"/>
+          <p:cNvSpPr/>
+          <p:nvPr/>
+        </p:nvSpPr>
+        <p:spPr>
+          <a:xfrm>
+            <a:off x="749808" y="1874519"/>
+            <a:ext cx="1207008" cy="256032"/>
+          </a:xfrm>
+          <a:prstGeom prst="roundRect">
+            <a:avLst/>
+          </a:prstGeom>
+          <a:solidFill>
+            <a:srgbClr val="E6BE5A"/>
+          </a:solidFill>
+          <a:ln>
+            <a:noFill/>
+          </a:ln>
+        </p:spPr>
+        <p:style>
+          <a:lnRef idx="1">
+            <a:schemeClr val="accent1"/>
+          </a:lnRef>
+          <a:fillRef idx="3">
+            <a:schemeClr val="accent1"/>
+          </a:fillRef>
+          <a:effectRef idx="2">
+            <a:schemeClr val="accent1"/>
+          </a:effectRef>
+          <a:fontRef idx="minor">
+            <a:schemeClr val="lt1"/>
+          </a:fontRef>
+        </p:style>
+        <p:txBody>
+          <a:bodyPr rtlCol="0" anchor="ctr"/>
+          <a:lstStyle/>
+          <a:p>
+            <a:pPr algn="ctr"/>
+            <a:r>
+              <a:rPr sz="1000" b="1">
+                <a:solidFill>
+                  <a:srgbClr val="121B26"/>
+                </a:solidFill>
+              </a:rPr>
+              <a:t>Web UI</a:t>
+            </a:r>
+          </a:p>
+        </p:txBody>
+      </p:sp>
       <p:pic>
         <p:nvPicPr>
-          <p:cNvPr id="7" name="Picture 6" descr="configuration-settings.png"/>
+          <p:cNvPr id="9" name="Picture 8" descr="configuration-settings.png"/>
           <p:cNvPicPr>
             <a:picLocks noChangeAspect="1"/>
           </p:cNvPicPr>
@@ -6460,8 +6554,8 @@
         </p:blipFill>
         <p:spPr>
           <a:xfrm>
-            <a:off x="667512" y="1828800"/>
-            <a:ext cx="7498079" cy="4114800"/>
+            <a:off x="713232" y="2084831"/>
+            <a:ext cx="7132320" cy="3511296"/>
           </a:xfrm>
           <a:prstGeom prst="rect">
             <a:avLst/>
@@ -6470,7 +6564,7 @@
       </p:pic>
       <p:sp>
         <p:nvSpPr>
-          <p:cNvPr id="8" name="Rounded Rectangle 7"/>
+          <p:cNvPr id="10" name="Rounded Rectangle 9"/>
           <p:cNvSpPr/>
           <p:nvPr/>
         </p:nvSpPr>
@@ -6515,7 +6609,7 @@
       </p:sp>
       <p:sp>
         <p:nvSpPr>
-          <p:cNvPr id="9" name="TextBox 8"/>
+          <p:cNvPr id="11" name="TextBox 10"/>
           <p:cNvSpPr txBox="1"/>
           <p:nvPr/>
         </p:nvSpPr>
@@ -6548,7 +6642,7 @@
       </p:sp>
       <p:sp>
         <p:nvSpPr>
-          <p:cNvPr id="10" name="TextBox 9"/>
+          <p:cNvPr id="12" name="TextBox 11"/>
           <p:cNvSpPr txBox="1"/>
           <p:nvPr/>
         </p:nvSpPr>
@@ -6666,7 +6760,7 @@
       </p:sp>
       <p:sp>
         <p:nvSpPr>
-          <p:cNvPr id="11" name="TextBox 10"/>
+          <p:cNvPr id="13" name="TextBox 12"/>
           <p:cNvSpPr txBox="1"/>
           <p:nvPr/>
         </p:nvSpPr>
@@ -6700,7 +6794,7 @@
       </p:sp>
       <p:sp>
         <p:nvSpPr>
-          <p:cNvPr id="12" name="TextBox 11"/>
+          <p:cNvPr id="14" name="TextBox 13"/>
           <p:cNvSpPr txBox="1"/>
           <p:nvPr/>
         </p:nvSpPr>

</xml_diff>